<commit_message>
Refactor code and enhance maintainability.
</commit_message>
<xml_diff>
--- a/reports/Kairos_Deck.pptx
+++ b/reports/Kairos_Deck.pptx
@@ -18,6 +18,9 @@
     <p:sldId id="266" r:id="rId17"/>
     <p:sldId id="267" r:id="rId18"/>
     <p:sldId id="268" r:id="rId19"/>
+    <p:sldId id="269" r:id="rId20"/>
+    <p:sldId id="270" r:id="rId21"/>
+    <p:sldId id="271" r:id="rId22"/>
   </p:sldIdLst>
   <p:sldSz cx="12191695" cy="6858000" type="screen4x3"/>
   <p:notesSz cx="6858000" cy="9144000"/>
@@ -3250,7 +3253,7 @@
               </a:defRPr>
             </a:pPr>
             <a:r>
-              <a:t>Overlay ablation</a:t>
+              <a:t>Statistical significance</a:t>
             </a:r>
           </a:p>
         </p:txBody>
@@ -3263,8 +3266,8 @@
         </p:nvSpPr>
         <p:spPr>
           <a:xfrm>
-            <a:off x="457200" y="1371600"/>
-            <a:ext cx="7680959" cy="4480560"/>
+            <a:off x="731520" y="1371600"/>
+            <a:ext cx="5943600" cy="4480560"/>
           </a:xfrm>
           <a:prstGeom prst="rect">
             <a:avLst/>
@@ -3300,7 +3303,7 @@
       </p:sp>
       <p:pic>
         <p:nvPicPr>
-          <p:cNvPr id="5" name="Picture 4" descr="14_overlay_ablation.png"/>
+          <p:cNvPr id="5" name="Picture 4" descr="09_sharpe_significance.png"/>
           <p:cNvPicPr>
             <a:picLocks noChangeAspect="1"/>
           </p:cNvPicPr>
@@ -3314,8 +3317,8 @@
         </p:blipFill>
         <p:spPr>
           <a:xfrm>
-            <a:off x="548640" y="1463040"/>
-            <a:ext cx="7498079" cy="2849270"/>
+            <a:off x="822960" y="1463040"/>
+            <a:ext cx="5760720" cy="3127248"/>
           </a:xfrm>
           <a:prstGeom prst="rect">
             <a:avLst/>
@@ -3330,8 +3333,8 @@
         </p:nvSpPr>
         <p:spPr>
           <a:xfrm>
-            <a:off x="8321040" y="1645920"/>
-            <a:ext cx="3566160" cy="4114800"/>
+            <a:off x="6949440" y="1645920"/>
+            <a:ext cx="4754880" cy="4114800"/>
           </a:xfrm>
           <a:prstGeom prst="rect">
             <a:avLst/>
@@ -3356,7 +3359,7 @@
               </a:defRPr>
             </a:pPr>
             <a:r>
-              <a:t>Same stress rule on 60/40: Sharpe 0.98 against 0.98</a:t>
+              <a:t>Regime ablation, Sharpe difference: -0.02 (95% interval -0.15 to 0.10, p = 0.791), not statistically significant</a:t>
             </a:r>
           </a:p>
           <a:p>
@@ -3372,23 +3375,7 @@
               </a:defRPr>
             </a:pPr>
             <a:r>
-              <a:t>Max drawdown -13.1% against -20.5%</a:t>
-            </a:r>
-          </a:p>
-          <a:p>
-            <a:pPr>
-              <a:spcAft>
-                <a:spcPts val="800"/>
-              </a:spcAft>
-              <a:defRPr sz="1600" b="0">
-                <a:solidFill>
-                  <a:srgbClr val="F2F4F8"/>
-                </a:solidFill>
-                <a:latin typeface="Calibri"/>
-              </a:defRPr>
-            </a:pPr>
-            <a:r>
-              <a:t>Naive historical-mean views: Sharpe 0.89</a:t>
+              <a:t>In stressed months the regime-aware portfolio's worst-5% average monthly return was -4.29% against -7.08% without regime scaling.</a:t>
             </a:r>
           </a:p>
         </p:txBody>
@@ -3496,7 +3483,7 @@
               </a:defRPr>
             </a:pPr>
             <a:r>
-              <a:t>Performance by regime</a:t>
+              <a:t>Overlay ablation</a:t>
             </a:r>
           </a:p>
         </p:txBody>
@@ -3509,8 +3496,8 @@
         </p:nvSpPr>
         <p:spPr>
           <a:xfrm>
-            <a:off x="1920240" y="1371600"/>
-            <a:ext cx="8046720" cy="4480560"/>
+            <a:off x="457200" y="1371600"/>
+            <a:ext cx="7680959" cy="4480560"/>
           </a:xfrm>
           <a:prstGeom prst="rect">
             <a:avLst/>
@@ -3546,7 +3533,7 @@
       </p:sp>
       <p:pic>
         <p:nvPicPr>
-          <p:cNvPr id="5" name="Picture 4" descr="10_regime_performance.png"/>
+          <p:cNvPr id="5" name="Picture 4" descr="14_overlay_ablation.png"/>
           <p:cNvPicPr>
             <a:picLocks noChangeAspect="1"/>
           </p:cNvPicPr>
@@ -3560,14 +3547,85 @@
         </p:blipFill>
         <p:spPr>
           <a:xfrm>
-            <a:off x="2011680" y="1463040"/>
-            <a:ext cx="7863840" cy="3538728"/>
+            <a:off x="548640" y="1463040"/>
+            <a:ext cx="7498079" cy="3149193"/>
           </a:xfrm>
           <a:prstGeom prst="rect">
             <a:avLst/>
           </a:prstGeom>
         </p:spPr>
       </p:pic>
+      <p:sp>
+        <p:nvSpPr>
+          <p:cNvPr id="6" name="TextBox 5"/>
+          <p:cNvSpPr txBox="1"/>
+          <p:nvPr/>
+        </p:nvSpPr>
+        <p:spPr>
+          <a:xfrm>
+            <a:off x="8321040" y="1645920"/>
+            <a:ext cx="3566160" cy="4114800"/>
+          </a:xfrm>
+          <a:prstGeom prst="rect">
+            <a:avLst/>
+          </a:prstGeom>
+          <a:noFill/>
+        </p:spPr>
+        <p:txBody>
+          <a:bodyPr wrap="square">
+            <a:spAutoFit/>
+          </a:bodyPr>
+          <a:lstStyle/>
+          <a:p>
+            <a:pPr>
+              <a:spcAft>
+                <a:spcPts val="800"/>
+              </a:spcAft>
+              <a:defRPr sz="1600" b="0">
+                <a:solidFill>
+                  <a:srgbClr val="F2F4F8"/>
+                </a:solidFill>
+                <a:latin typeface="Calibri"/>
+              </a:defRPr>
+            </a:pPr>
+            <a:r>
+              <a:t>Same stress rule on 60/40: Sharpe 0.98 against 0.98</a:t>
+            </a:r>
+          </a:p>
+          <a:p>
+            <a:pPr>
+              <a:spcAft>
+                <a:spcPts val="800"/>
+              </a:spcAft>
+              <a:defRPr sz="1600" b="0">
+                <a:solidFill>
+                  <a:srgbClr val="F2F4F8"/>
+                </a:solidFill>
+                <a:latin typeface="Calibri"/>
+              </a:defRPr>
+            </a:pPr>
+            <a:r>
+              <a:t>Max drawdown -13.1% against -20.5%</a:t>
+            </a:r>
+          </a:p>
+          <a:p>
+            <a:pPr>
+              <a:spcAft>
+                <a:spcPts val="800"/>
+              </a:spcAft>
+              <a:defRPr sz="1600" b="0">
+                <a:solidFill>
+                  <a:srgbClr val="F2F4F8"/>
+                </a:solidFill>
+                <a:latin typeface="Calibri"/>
+              </a:defRPr>
+            </a:pPr>
+            <a:r>
+              <a:t>Naive historical-mean views: Sharpe 0.89</a:t>
+            </a:r>
+          </a:p>
+        </p:txBody>
+      </p:sp>
     </p:spTree>
   </p:cSld>
   <p:clrMapOvr>
@@ -3671,7 +3729,7 @@
               </a:defRPr>
             </a:pPr>
             <a:r>
-              <a:t>Parameter sensitivity</a:t>
+              <a:t>Other evaluation windows</a:t>
             </a:r>
           </a:p>
         </p:txBody>
@@ -3684,8 +3742,8 @@
         </p:nvSpPr>
         <p:spPr>
           <a:xfrm>
-            <a:off x="1371600" y="1280160"/>
-            <a:ext cx="7863840" cy="4480560"/>
+            <a:off x="365760" y="1371600"/>
+            <a:ext cx="7680959" cy="4480560"/>
           </a:xfrm>
           <a:prstGeom prst="rect">
             <a:avLst/>
@@ -3721,7 +3779,7 @@
       </p:sp>
       <p:pic>
         <p:nvPicPr>
-          <p:cNvPr id="5" name="Picture 4" descr="13_sensitivity.png"/>
+          <p:cNvPr id="5" name="Picture 4" descr="16_window_robustness.png"/>
           <p:cNvPicPr>
             <a:picLocks noChangeAspect="1"/>
           </p:cNvPicPr>
@@ -3735,8 +3793,8 @@
         </p:blipFill>
         <p:spPr>
           <a:xfrm>
-            <a:off x="1463040" y="1371600"/>
-            <a:ext cx="7680960" cy="4301338"/>
+            <a:off x="457200" y="1463040"/>
+            <a:ext cx="7498079" cy="2849270"/>
           </a:xfrm>
           <a:prstGeom prst="rect">
             <a:avLst/>
@@ -3751,8 +3809,8 @@
         </p:nvSpPr>
         <p:spPr>
           <a:xfrm>
-            <a:off x="9418320" y="1645920"/>
-            <a:ext cx="2560320" cy="4114800"/>
+            <a:off x="8229600" y="1645920"/>
+            <a:ext cx="3657600" cy="4114800"/>
           </a:xfrm>
           <a:prstGeom prst="rect">
             <a:avLst/>
@@ -3769,7 +3827,7 @@
               <a:spcAft>
                 <a:spcPts val="800"/>
               </a:spcAft>
-              <a:defRPr sz="1400" b="0">
+              <a:defRPr sz="1500" b="0">
                 <a:solidFill>
                   <a:srgbClr val="F2F4F8"/>
                 </a:solidFill>
@@ -3777,7 +3835,7 @@
               </a:defRPr>
             </a:pPr>
             <a:r>
-              <a:t>Runs above 60/40 Sharpe: 0 of 42</a:t>
+              <a:t>Window starts 2007-01-31, includes 2008</a:t>
             </a:r>
           </a:p>
           <a:p>
@@ -3785,7 +3843,7 @@
               <a:spcAft>
                 <a:spcPts val="800"/>
               </a:spcAft>
-              <a:defRPr sz="1400" b="0">
+              <a:defRPr sz="1500" b="0">
                 <a:solidFill>
                   <a:srgbClr val="F2F4F8"/>
                 </a:solidFill>
@@ -3793,7 +3851,39 @@
               </a:defRPr>
             </a:pPr>
             <a:r>
-              <a:t>Sharpe range: 0.57 to 0.90</a:t>
+              <a:t>Max drawdown static 60/40: -29.5%</a:t>
+            </a:r>
+          </a:p>
+          <a:p>
+            <a:pPr>
+              <a:spcAft>
+                <a:spcPts val="800"/>
+              </a:spcAft>
+              <a:defRPr sz="1500" b="0">
+                <a:solidFill>
+                  <a:srgbClr val="F2F4F8"/>
+                </a:solidFill>
+                <a:latin typeface="Calibri"/>
+              </a:defRPr>
+            </a:pPr>
+            <a:r>
+              <a:t>Max drawdown Regime_60_40: -16.6%</a:t>
+            </a:r>
+          </a:p>
+          <a:p>
+            <a:pPr>
+              <a:spcAft>
+                <a:spcPts val="800"/>
+              </a:spcAft>
+              <a:defRPr sz="1500" b="0">
+                <a:solidFill>
+                  <a:srgbClr val="F2F4F8"/>
+                </a:solidFill>
+                <a:latin typeface="Calibri"/>
+              </a:defRPr>
+            </a:pPr>
+            <a:r>
+              <a:t>BL_ML_Regime Sharpe: 0.71</a:t>
             </a:r>
           </a:p>
         </p:txBody>
@@ -3901,6 +3991,657 @@
               </a:defRPr>
             </a:pPr>
             <a:r>
+              <a:t>Performance by regime</a:t>
+            </a:r>
+          </a:p>
+        </p:txBody>
+      </p:sp>
+      <p:sp>
+        <p:nvSpPr>
+          <p:cNvPr id="4" name="Rectangle 3"/>
+          <p:cNvSpPr/>
+          <p:nvPr/>
+        </p:nvSpPr>
+        <p:spPr>
+          <a:xfrm>
+            <a:off x="1920240" y="1371600"/>
+            <a:ext cx="8046720" cy="4480560"/>
+          </a:xfrm>
+          <a:prstGeom prst="rect">
+            <a:avLst/>
+          </a:prstGeom>
+          <a:solidFill>
+            <a:srgbClr val="FFFFFF"/>
+          </a:solidFill>
+          <a:ln>
+            <a:noFill/>
+          </a:ln>
+        </p:spPr>
+        <p:style>
+          <a:lnRef idx="1">
+            <a:schemeClr val="accent1"/>
+          </a:lnRef>
+          <a:fillRef idx="3">
+            <a:schemeClr val="accent1"/>
+          </a:fillRef>
+          <a:effectRef idx="2">
+            <a:schemeClr val="accent1"/>
+          </a:effectRef>
+          <a:fontRef idx="minor">
+            <a:schemeClr val="lt1"/>
+          </a:fontRef>
+        </p:style>
+        <p:txBody>
+          <a:bodyPr rtlCol="0" anchor="ctr"/>
+          <a:lstStyle/>
+          <a:p>
+            <a:pPr algn="ctr"/>
+          </a:p>
+        </p:txBody>
+      </p:sp>
+      <p:pic>
+        <p:nvPicPr>
+          <p:cNvPr id="5" name="Picture 4" descr="10_regime_performance.png"/>
+          <p:cNvPicPr>
+            <a:picLocks noChangeAspect="1"/>
+          </p:cNvPicPr>
+          <p:nvPr/>
+        </p:nvPicPr>
+        <p:blipFill>
+          <a:blip r:embed="rId2"/>
+          <a:stretch>
+            <a:fillRect/>
+          </a:stretch>
+        </p:blipFill>
+        <p:spPr>
+          <a:xfrm>
+            <a:off x="2011680" y="1463040"/>
+            <a:ext cx="7863840" cy="3538728"/>
+          </a:xfrm>
+          <a:prstGeom prst="rect">
+            <a:avLst/>
+          </a:prstGeom>
+        </p:spPr>
+      </p:pic>
+    </p:spTree>
+  </p:cSld>
+  <p:clrMapOvr>
+    <a:masterClrMapping/>
+  </p:clrMapOvr>
+</p:sld>
+</file>
+
+<file path=ppt/slides/slide14.xml><?xml version="1.0" encoding="utf-8"?>
+<p:sld xmlns:a="http://schemas.openxmlformats.org/drawingml/2006/main" xmlns:p="http://schemas.openxmlformats.org/presentationml/2006/main" xmlns:r="http://schemas.openxmlformats.org/officeDocument/2006/relationships">
+  <p:cSld>
+    <p:bg>
+      <p:bgPr>
+        <a:solidFill>
+          <a:srgbClr val="0B0F17"/>
+        </a:solidFill>
+        <a:effectLst/>
+      </p:bgPr>
+    </p:bg>
+    <p:spTree>
+      <p:nvGrpSpPr>
+        <p:cNvPr id="1" name=""/>
+        <p:cNvGrpSpPr/>
+        <p:nvPr/>
+      </p:nvGrpSpPr>
+      <p:grpSpPr/>
+      <p:sp>
+        <p:nvSpPr>
+          <p:cNvPr id="2" name="Rectangle 1"/>
+          <p:cNvSpPr/>
+          <p:nvPr/>
+        </p:nvSpPr>
+        <p:spPr>
+          <a:xfrm>
+            <a:off x="548640" y="502920"/>
+            <a:ext cx="73152" cy="548640"/>
+          </a:xfrm>
+          <a:prstGeom prst="rect">
+            <a:avLst/>
+          </a:prstGeom>
+          <a:solidFill>
+            <a:srgbClr val="3DD6C6"/>
+          </a:solidFill>
+          <a:ln>
+            <a:noFill/>
+          </a:ln>
+        </p:spPr>
+        <p:style>
+          <a:lnRef idx="1">
+            <a:schemeClr val="accent1"/>
+          </a:lnRef>
+          <a:fillRef idx="3">
+            <a:schemeClr val="accent1"/>
+          </a:fillRef>
+          <a:effectRef idx="2">
+            <a:schemeClr val="accent1"/>
+          </a:effectRef>
+          <a:fontRef idx="minor">
+            <a:schemeClr val="lt1"/>
+          </a:fontRef>
+        </p:style>
+        <p:txBody>
+          <a:bodyPr rtlCol="0" anchor="ctr"/>
+          <a:lstStyle/>
+          <a:p>
+            <a:pPr algn="ctr"/>
+          </a:p>
+        </p:txBody>
+      </p:sp>
+      <p:sp>
+        <p:nvSpPr>
+          <p:cNvPr id="3" name="TextBox 2"/>
+          <p:cNvSpPr txBox="1"/>
+          <p:nvPr/>
+        </p:nvSpPr>
+        <p:spPr>
+          <a:xfrm>
+            <a:off x="777240" y="411480"/>
+            <a:ext cx="10515600" cy="731520"/>
+          </a:xfrm>
+          <a:prstGeom prst="rect">
+            <a:avLst/>
+          </a:prstGeom>
+          <a:noFill/>
+        </p:spPr>
+        <p:txBody>
+          <a:bodyPr wrap="square">
+            <a:spAutoFit/>
+          </a:bodyPr>
+          <a:lstStyle/>
+          <a:p>
+            <a:pPr>
+              <a:spcAft>
+                <a:spcPts val="800"/>
+              </a:spcAft>
+              <a:defRPr sz="3000" b="1">
+                <a:solidFill>
+                  <a:srgbClr val="F2F4F8"/>
+                </a:solidFill>
+                <a:latin typeface="Calibri"/>
+              </a:defRPr>
+            </a:pPr>
+            <a:r>
+              <a:t>Parameter sensitivity</a:t>
+            </a:r>
+          </a:p>
+        </p:txBody>
+      </p:sp>
+      <p:sp>
+        <p:nvSpPr>
+          <p:cNvPr id="4" name="Rectangle 3"/>
+          <p:cNvSpPr/>
+          <p:nvPr/>
+        </p:nvSpPr>
+        <p:spPr>
+          <a:xfrm>
+            <a:off x="1371600" y="1280160"/>
+            <a:ext cx="7863840" cy="4480560"/>
+          </a:xfrm>
+          <a:prstGeom prst="rect">
+            <a:avLst/>
+          </a:prstGeom>
+          <a:solidFill>
+            <a:srgbClr val="FFFFFF"/>
+          </a:solidFill>
+          <a:ln>
+            <a:noFill/>
+          </a:ln>
+        </p:spPr>
+        <p:style>
+          <a:lnRef idx="1">
+            <a:schemeClr val="accent1"/>
+          </a:lnRef>
+          <a:fillRef idx="3">
+            <a:schemeClr val="accent1"/>
+          </a:fillRef>
+          <a:effectRef idx="2">
+            <a:schemeClr val="accent1"/>
+          </a:effectRef>
+          <a:fontRef idx="minor">
+            <a:schemeClr val="lt1"/>
+          </a:fontRef>
+        </p:style>
+        <p:txBody>
+          <a:bodyPr rtlCol="0" anchor="ctr"/>
+          <a:lstStyle/>
+          <a:p>
+            <a:pPr algn="ctr"/>
+          </a:p>
+        </p:txBody>
+      </p:sp>
+      <p:pic>
+        <p:nvPicPr>
+          <p:cNvPr id="5" name="Picture 4" descr="13_sensitivity.png"/>
+          <p:cNvPicPr>
+            <a:picLocks noChangeAspect="1"/>
+          </p:cNvPicPr>
+          <p:nvPr/>
+        </p:nvPicPr>
+        <p:blipFill>
+          <a:blip r:embed="rId2"/>
+          <a:stretch>
+            <a:fillRect/>
+          </a:stretch>
+        </p:blipFill>
+        <p:spPr>
+          <a:xfrm>
+            <a:off x="1463040" y="1371600"/>
+            <a:ext cx="7680960" cy="4301338"/>
+          </a:xfrm>
+          <a:prstGeom prst="rect">
+            <a:avLst/>
+          </a:prstGeom>
+        </p:spPr>
+      </p:pic>
+      <p:sp>
+        <p:nvSpPr>
+          <p:cNvPr id="6" name="TextBox 5"/>
+          <p:cNvSpPr txBox="1"/>
+          <p:nvPr/>
+        </p:nvSpPr>
+        <p:spPr>
+          <a:xfrm>
+            <a:off x="9418320" y="1645920"/>
+            <a:ext cx="2560320" cy="4114800"/>
+          </a:xfrm>
+          <a:prstGeom prst="rect">
+            <a:avLst/>
+          </a:prstGeom>
+          <a:noFill/>
+        </p:spPr>
+        <p:txBody>
+          <a:bodyPr wrap="square">
+            <a:spAutoFit/>
+          </a:bodyPr>
+          <a:lstStyle/>
+          <a:p>
+            <a:pPr>
+              <a:spcAft>
+                <a:spcPts val="800"/>
+              </a:spcAft>
+              <a:defRPr sz="1400" b="0">
+                <a:solidFill>
+                  <a:srgbClr val="F2F4F8"/>
+                </a:solidFill>
+                <a:latin typeface="Calibri"/>
+              </a:defRPr>
+            </a:pPr>
+            <a:r>
+              <a:t>Runs above 60/40 Sharpe: 0 of 44</a:t>
+            </a:r>
+          </a:p>
+          <a:p>
+            <a:pPr>
+              <a:spcAft>
+                <a:spcPts val="800"/>
+              </a:spcAft>
+              <a:defRPr sz="1400" b="0">
+                <a:solidFill>
+                  <a:srgbClr val="F2F4F8"/>
+                </a:solidFill>
+                <a:latin typeface="Calibri"/>
+              </a:defRPr>
+            </a:pPr>
+            <a:r>
+              <a:t>Sharpe range: 0.61 to 0.90</a:t>
+            </a:r>
+          </a:p>
+        </p:txBody>
+      </p:sp>
+    </p:spTree>
+  </p:cSld>
+  <p:clrMapOvr>
+    <a:masterClrMapping/>
+  </p:clrMapOvr>
+</p:sld>
+</file>
+
+<file path=ppt/slides/slide15.xml><?xml version="1.0" encoding="utf-8"?>
+<p:sld xmlns:a="http://schemas.openxmlformats.org/drawingml/2006/main" xmlns:p="http://schemas.openxmlformats.org/presentationml/2006/main" xmlns:r="http://schemas.openxmlformats.org/officeDocument/2006/relationships">
+  <p:cSld>
+    <p:bg>
+      <p:bgPr>
+        <a:solidFill>
+          <a:srgbClr val="0B0F17"/>
+        </a:solidFill>
+        <a:effectLst/>
+      </p:bgPr>
+    </p:bg>
+    <p:spTree>
+      <p:nvGrpSpPr>
+        <p:cNvPr id="1" name=""/>
+        <p:cNvGrpSpPr/>
+        <p:nvPr/>
+      </p:nvGrpSpPr>
+      <p:grpSpPr/>
+      <p:sp>
+        <p:nvSpPr>
+          <p:cNvPr id="2" name="Rectangle 1"/>
+          <p:cNvSpPr/>
+          <p:nvPr/>
+        </p:nvSpPr>
+        <p:spPr>
+          <a:xfrm>
+            <a:off x="548640" y="502920"/>
+            <a:ext cx="73152" cy="548640"/>
+          </a:xfrm>
+          <a:prstGeom prst="rect">
+            <a:avLst/>
+          </a:prstGeom>
+          <a:solidFill>
+            <a:srgbClr val="3DD6C6"/>
+          </a:solidFill>
+          <a:ln>
+            <a:noFill/>
+          </a:ln>
+        </p:spPr>
+        <p:style>
+          <a:lnRef idx="1">
+            <a:schemeClr val="accent1"/>
+          </a:lnRef>
+          <a:fillRef idx="3">
+            <a:schemeClr val="accent1"/>
+          </a:fillRef>
+          <a:effectRef idx="2">
+            <a:schemeClr val="accent1"/>
+          </a:effectRef>
+          <a:fontRef idx="minor">
+            <a:schemeClr val="lt1"/>
+          </a:fontRef>
+        </p:style>
+        <p:txBody>
+          <a:bodyPr rtlCol="0" anchor="ctr"/>
+          <a:lstStyle/>
+          <a:p>
+            <a:pPr algn="ctr"/>
+          </a:p>
+        </p:txBody>
+      </p:sp>
+      <p:sp>
+        <p:nvSpPr>
+          <p:cNvPr id="3" name="TextBox 2"/>
+          <p:cNvSpPr txBox="1"/>
+          <p:nvPr/>
+        </p:nvSpPr>
+        <p:spPr>
+          <a:xfrm>
+            <a:off x="777240" y="411480"/>
+            <a:ext cx="10515600" cy="731520"/>
+          </a:xfrm>
+          <a:prstGeom prst="rect">
+            <a:avLst/>
+          </a:prstGeom>
+          <a:noFill/>
+        </p:spPr>
+        <p:txBody>
+          <a:bodyPr wrap="square">
+            <a:spAutoFit/>
+          </a:bodyPr>
+          <a:lstStyle/>
+          <a:p>
+            <a:pPr>
+              <a:spcAft>
+                <a:spcPts val="800"/>
+              </a:spcAft>
+              <a:defRPr sz="3000" b="1">
+                <a:solidFill>
+                  <a:srgbClr val="F2F4F8"/>
+                </a:solidFill>
+                <a:latin typeface="Calibri"/>
+              </a:defRPr>
+            </a:pPr>
+            <a:r>
+              <a:t>Prior dependence</a:t>
+            </a:r>
+          </a:p>
+        </p:txBody>
+      </p:sp>
+      <p:sp>
+        <p:nvSpPr>
+          <p:cNvPr id="4" name="Rectangle 3"/>
+          <p:cNvSpPr/>
+          <p:nvPr/>
+        </p:nvSpPr>
+        <p:spPr>
+          <a:xfrm>
+            <a:off x="365760" y="1371600"/>
+            <a:ext cx="7680959" cy="4480560"/>
+          </a:xfrm>
+          <a:prstGeom prst="rect">
+            <a:avLst/>
+          </a:prstGeom>
+          <a:solidFill>
+            <a:srgbClr val="FFFFFF"/>
+          </a:solidFill>
+          <a:ln>
+            <a:noFill/>
+          </a:ln>
+        </p:spPr>
+        <p:style>
+          <a:lnRef idx="1">
+            <a:schemeClr val="accent1"/>
+          </a:lnRef>
+          <a:fillRef idx="3">
+            <a:schemeClr val="accent1"/>
+          </a:fillRef>
+          <a:effectRef idx="2">
+            <a:schemeClr val="accent1"/>
+          </a:effectRef>
+          <a:fontRef idx="minor">
+            <a:schemeClr val="lt1"/>
+          </a:fontRef>
+        </p:style>
+        <p:txBody>
+          <a:bodyPr rtlCol="0" anchor="ctr"/>
+          <a:lstStyle/>
+          <a:p>
+            <a:pPr algn="ctr"/>
+          </a:p>
+        </p:txBody>
+      </p:sp>
+      <p:pic>
+        <p:nvPicPr>
+          <p:cNvPr id="5" name="Picture 4" descr="17_prior_comparison.png"/>
+          <p:cNvPicPr>
+            <a:picLocks noChangeAspect="1"/>
+          </p:cNvPicPr>
+          <p:nvPr/>
+        </p:nvPicPr>
+        <p:blipFill>
+          <a:blip r:embed="rId2"/>
+          <a:stretch>
+            <a:fillRect/>
+          </a:stretch>
+        </p:blipFill>
+        <p:spPr>
+          <a:xfrm>
+            <a:off x="457200" y="1463040"/>
+            <a:ext cx="7498079" cy="3165856"/>
+          </a:xfrm>
+          <a:prstGeom prst="rect">
+            <a:avLst/>
+          </a:prstGeom>
+        </p:spPr>
+      </p:pic>
+      <p:sp>
+        <p:nvSpPr>
+          <p:cNvPr id="6" name="TextBox 5"/>
+          <p:cNvSpPr txBox="1"/>
+          <p:nvPr/>
+        </p:nvSpPr>
+        <p:spPr>
+          <a:xfrm>
+            <a:off x="8229600" y="1645920"/>
+            <a:ext cx="3657600" cy="4114800"/>
+          </a:xfrm>
+          <a:prstGeom prst="rect">
+            <a:avLst/>
+          </a:prstGeom>
+          <a:noFill/>
+        </p:spPr>
+        <p:txBody>
+          <a:bodyPr wrap="square">
+            <a:spAutoFit/>
+          </a:bodyPr>
+          <a:lstStyle/>
+          <a:p>
+            <a:pPr>
+              <a:spcAft>
+                <a:spcPts val="800"/>
+              </a:spcAft>
+              <a:defRPr sz="1400" b="0">
+                <a:solidFill>
+                  <a:srgbClr val="F2F4F8"/>
+                </a:solidFill>
+                <a:latin typeface="Calibri"/>
+              </a:defRPr>
+            </a:pPr>
+            <a:r>
+              <a:t>reference: Sharpe gain over its prior portfolio -0.08 (p = 0.32)</a:t>
+            </a:r>
+          </a:p>
+          <a:p>
+            <a:pPr>
+              <a:spcAft>
+                <a:spcPts val="800"/>
+              </a:spcAft>
+              <a:defRPr sz="1400" b="0">
+                <a:solidFill>
+                  <a:srgbClr val="F2F4F8"/>
+                </a:solidFill>
+                <a:latin typeface="Calibri"/>
+              </a:defRPr>
+            </a:pPr>
+            <a:r>
+              <a:t>equal: Sharpe gain over its prior portfolio -0.13 (p = 0.09)</a:t>
+            </a:r>
+          </a:p>
+          <a:p>
+            <a:pPr>
+              <a:spcAft>
+                <a:spcPts val="800"/>
+              </a:spcAft>
+              <a:defRPr sz="1400" b="0">
+                <a:solidFill>
+                  <a:srgbClr val="F2F4F8"/>
+                </a:solidFill>
+                <a:latin typeface="Calibri"/>
+              </a:defRPr>
+            </a:pPr>
+            <a:r>
+              <a:t>inverse_vol: Sharpe gain over its prior portfolio -0.12 (p = 0.22)</a:t>
+            </a:r>
+          </a:p>
+        </p:txBody>
+      </p:sp>
+    </p:spTree>
+  </p:cSld>
+  <p:clrMapOvr>
+    <a:masterClrMapping/>
+  </p:clrMapOvr>
+</p:sld>
+</file>
+
+<file path=ppt/slides/slide16.xml><?xml version="1.0" encoding="utf-8"?>
+<p:sld xmlns:a="http://schemas.openxmlformats.org/drawingml/2006/main" xmlns:p="http://schemas.openxmlformats.org/presentationml/2006/main" xmlns:r="http://schemas.openxmlformats.org/officeDocument/2006/relationships">
+  <p:cSld>
+    <p:bg>
+      <p:bgPr>
+        <a:solidFill>
+          <a:srgbClr val="0B0F17"/>
+        </a:solidFill>
+        <a:effectLst/>
+      </p:bgPr>
+    </p:bg>
+    <p:spTree>
+      <p:nvGrpSpPr>
+        <p:cNvPr id="1" name=""/>
+        <p:cNvGrpSpPr/>
+        <p:nvPr/>
+      </p:nvGrpSpPr>
+      <p:grpSpPr/>
+      <p:sp>
+        <p:nvSpPr>
+          <p:cNvPr id="2" name="Rectangle 1"/>
+          <p:cNvSpPr/>
+          <p:nvPr/>
+        </p:nvSpPr>
+        <p:spPr>
+          <a:xfrm>
+            <a:off x="548640" y="502920"/>
+            <a:ext cx="73152" cy="548640"/>
+          </a:xfrm>
+          <a:prstGeom prst="rect">
+            <a:avLst/>
+          </a:prstGeom>
+          <a:solidFill>
+            <a:srgbClr val="3DD6C6"/>
+          </a:solidFill>
+          <a:ln>
+            <a:noFill/>
+          </a:ln>
+        </p:spPr>
+        <p:style>
+          <a:lnRef idx="1">
+            <a:schemeClr val="accent1"/>
+          </a:lnRef>
+          <a:fillRef idx="3">
+            <a:schemeClr val="accent1"/>
+          </a:fillRef>
+          <a:effectRef idx="2">
+            <a:schemeClr val="accent1"/>
+          </a:effectRef>
+          <a:fontRef idx="minor">
+            <a:schemeClr val="lt1"/>
+          </a:fontRef>
+        </p:style>
+        <p:txBody>
+          <a:bodyPr rtlCol="0" anchor="ctr"/>
+          <a:lstStyle/>
+          <a:p>
+            <a:pPr algn="ctr"/>
+          </a:p>
+        </p:txBody>
+      </p:sp>
+      <p:sp>
+        <p:nvSpPr>
+          <p:cNvPr id="3" name="TextBox 2"/>
+          <p:cNvSpPr txBox="1"/>
+          <p:nvPr/>
+        </p:nvSpPr>
+        <p:spPr>
+          <a:xfrm>
+            <a:off x="777240" y="411480"/>
+            <a:ext cx="10515600" cy="731520"/>
+          </a:xfrm>
+          <a:prstGeom prst="rect">
+            <a:avLst/>
+          </a:prstGeom>
+          <a:noFill/>
+        </p:spPr>
+        <p:txBody>
+          <a:bodyPr wrap="square">
+            <a:spAutoFit/>
+          </a:bodyPr>
+          <a:lstStyle/>
+          <a:p>
+            <a:pPr>
+              <a:spcAft>
+                <a:spcPts val="800"/>
+              </a:spcAft>
+              <a:defRPr sz="3000" b="1">
+                <a:solidFill>
+                  <a:srgbClr val="F2F4F8"/>
+                </a:solidFill>
+                <a:latin typeface="Calibri"/>
+              </a:defRPr>
+            </a:pPr>
+            <a:r>
               <a:t>Conclusions</a:t>
             </a:r>
           </a:p>
@@ -3940,7 +4681,7 @@
               </a:defRPr>
             </a:pPr>
             <a:r>
-              <a:t>The research hypothesis is not supported. The highest Sharpe ratio among the Kairos portfolios and the classical benchmarks belongs to Static_60_40. The Sharpe difference of BL_ML_Regime to the best classical benchmark (Static_60_40) is -0.20 (95% interval -0.53 to 0.07, p = 0.197), not statistically significant; BL_ML_Regime is significantly better than 1 and significantly worse than 0 of the 5 classical benchmarks (5% level). For BL_ML_Regime_IC the difference is -0.12 (95% interval -0.34 to 0.05, p = 0.233), not statistically significant.</a:t>
+              <a:t>The research hypothesis is not supported. The highest Sharpe ratio among the Kairos portfolios and the classical benchmarks belongs to Static_60_40. The Sharpe difference of BL_ML_Regime to the best classical benchmark (Static_60_40) is -0.14 (95% interval -0.38 to 0.06, p = 0.231), not statistically significant; BL_ML_Regime is significantly better than 1 and significantly worse than 0 of the 5 classical benchmarks (5% level). For BL_ML_Regime_IC the difference is -0.12 (95% interval -0.34 to 0.06, p = 0.234), not statistically significant.</a:t>
             </a:r>
           </a:p>
           <a:p>
@@ -3972,7 +4713,23 @@
               </a:defRPr>
             </a:pPr>
             <a:r>
-              <a:t>Limitations: about 15 years of monthly data, hand-picked reference prior, 2008 outside the backtest window.</a:t>
+              <a:t>Specification frozen at 2026-07-31; 0 new months evaluated so far.</a:t>
+            </a:r>
+          </a:p>
+          <a:p>
+            <a:pPr>
+              <a:spcAft>
+                <a:spcPts val="800"/>
+              </a:spcAft>
+              <a:defRPr sz="1800" b="0">
+                <a:solidFill>
+                  <a:srgbClr val="F2F4F8"/>
+                </a:solidFill>
+                <a:latin typeface="Calibri"/>
+              </a:defRPr>
+            </a:pPr>
+            <a:r>
+              <a:t>Limitations: about 15 years of monthly data, no observed market-capitalisation prior, repairs designed after seeing full-sample results.</a:t>
             </a:r>
           </a:p>
         </p:txBody>
@@ -4806,7 +5563,7 @@
               </a:defRPr>
             </a:pPr>
             <a:r>
-              <a:t>Mean stacked IC: -0.037</a:t>
+              <a:t>Mean stacked IC: -0.047</a:t>
             </a:r>
           </a:p>
           <a:p>
@@ -5100,7 +5857,7 @@
               </a:defRPr>
             </a:pPr>
             <a:r>
-              <a:t>as specified: mean IC -0.011</a:t>
+              <a:t>as specified: mean IC -0.008</a:t>
             </a:r>
           </a:p>
           <a:p>
@@ -5272,6 +6029,268 @@
               </a:defRPr>
             </a:pPr>
             <a:r>
+              <a:t>Repairing the forecasts</a:t>
+            </a:r>
+          </a:p>
+        </p:txBody>
+      </p:sp>
+      <p:sp>
+        <p:nvSpPr>
+          <p:cNvPr id="4" name="Rectangle 3"/>
+          <p:cNvSpPr/>
+          <p:nvPr/>
+        </p:nvSpPr>
+        <p:spPr>
+          <a:xfrm>
+            <a:off x="365760" y="1371600"/>
+            <a:ext cx="7680959" cy="4480560"/>
+          </a:xfrm>
+          <a:prstGeom prst="rect">
+            <a:avLst/>
+          </a:prstGeom>
+          <a:solidFill>
+            <a:srgbClr val="FFFFFF"/>
+          </a:solidFill>
+          <a:ln>
+            <a:noFill/>
+          </a:ln>
+        </p:spPr>
+        <p:style>
+          <a:lnRef idx="1">
+            <a:schemeClr val="accent1"/>
+          </a:lnRef>
+          <a:fillRef idx="3">
+            <a:schemeClr val="accent1"/>
+          </a:fillRef>
+          <a:effectRef idx="2">
+            <a:schemeClr val="accent1"/>
+          </a:effectRef>
+          <a:fontRef idx="minor">
+            <a:schemeClr val="lt1"/>
+          </a:fontRef>
+        </p:style>
+        <p:txBody>
+          <a:bodyPr rtlCol="0" anchor="ctr"/>
+          <a:lstStyle/>
+          <a:p>
+            <a:pPr algn="ctr"/>
+          </a:p>
+        </p:txBody>
+      </p:sp>
+      <p:pic>
+        <p:nvPicPr>
+          <p:cNvPr id="5" name="Picture 4" descr="15_forecast_repair.png"/>
+          <p:cNvPicPr>
+            <a:picLocks noChangeAspect="1"/>
+          </p:cNvPicPr>
+          <p:nvPr/>
+        </p:nvPicPr>
+        <p:blipFill>
+          <a:blip r:embed="rId2"/>
+          <a:stretch>
+            <a:fillRect/>
+          </a:stretch>
+        </p:blipFill>
+        <p:spPr>
+          <a:xfrm>
+            <a:off x="457200" y="1463040"/>
+            <a:ext cx="7498079" cy="2849270"/>
+          </a:xfrm>
+          <a:prstGeom prst="rect">
+            <a:avLst/>
+          </a:prstGeom>
+        </p:spPr>
+      </p:pic>
+      <p:sp>
+        <p:nvSpPr>
+          <p:cNvPr id="6" name="TextBox 5"/>
+          <p:cNvSpPr txBox="1"/>
+          <p:nvPr/>
+        </p:nvSpPr>
+        <p:spPr>
+          <a:xfrm>
+            <a:off x="8229600" y="1645920"/>
+            <a:ext cx="3657600" cy="4114800"/>
+          </a:xfrm>
+          <a:prstGeom prst="rect">
+            <a:avLst/>
+          </a:prstGeom>
+          <a:noFill/>
+        </p:spPr>
+        <p:txBody>
+          <a:bodyPr wrap="square">
+            <a:spAutoFit/>
+          </a:bodyPr>
+          <a:lstStyle/>
+          <a:p>
+            <a:pPr>
+              <a:spcAft>
+                <a:spcPts val="800"/>
+              </a:spcAft>
+              <a:defRPr sz="1500" b="0">
+                <a:solidFill>
+                  <a:srgbClr val="F2F4F8"/>
+                </a:solidFill>
+                <a:latin typeface="Calibri"/>
+              </a:defRPr>
+            </a:pPr>
+            <a:r>
+              <a:t>LSTM dispersion 1.9x to 0.34x realised returns</a:t>
+            </a:r>
+          </a:p>
+          <a:p>
+            <a:pPr>
+              <a:spcAft>
+                <a:spcPts val="800"/>
+              </a:spcAft>
+              <a:defRPr sz="1500" b="0">
+                <a:solidFill>
+                  <a:srgbClr val="F2F4F8"/>
+                </a:solidFill>
+                <a:latin typeface="Calibri"/>
+              </a:defRPr>
+            </a:pPr>
+            <a:r>
+              <a:t>LSTM mean R2 -3.8 to -0.16</a:t>
+            </a:r>
+          </a:p>
+          <a:p>
+            <a:pPr>
+              <a:spcAft>
+                <a:spcPts val="800"/>
+              </a:spcAft>
+              <a:defRPr sz="1500" b="0">
+                <a:solidFill>
+                  <a:srgbClr val="F2F4F8"/>
+                </a:solidFill>
+                <a:latin typeface="Calibri"/>
+              </a:defRPr>
+            </a:pPr>
+            <a:r>
+              <a:t>Calibrated forecast R2: -0.019 before, -0.012 after 2019</a:t>
+            </a:r>
+          </a:p>
+          <a:p>
+            <a:pPr>
+              <a:spcAft>
+                <a:spcPts val="800"/>
+              </a:spcAft>
+              <a:defRPr sz="1500" b="0">
+                <a:solidFill>
+                  <a:srgbClr val="F2F4F8"/>
+                </a:solidFill>
+                <a:latin typeface="Calibri"/>
+              </a:defRPr>
+            </a:pPr>
+            <a:r>
+              <a:t>No forecast beats the historical mean in either period</a:t>
+            </a:r>
+          </a:p>
+        </p:txBody>
+      </p:sp>
+    </p:spTree>
+  </p:cSld>
+  <p:clrMapOvr>
+    <a:masterClrMapping/>
+  </p:clrMapOvr>
+</p:sld>
+</file>
+
+<file path=ppt/slides/slide8.xml><?xml version="1.0" encoding="utf-8"?>
+<p:sld xmlns:a="http://schemas.openxmlformats.org/drawingml/2006/main" xmlns:p="http://schemas.openxmlformats.org/presentationml/2006/main" xmlns:r="http://schemas.openxmlformats.org/officeDocument/2006/relationships">
+  <p:cSld>
+    <p:bg>
+      <p:bgPr>
+        <a:solidFill>
+          <a:srgbClr val="0B0F17"/>
+        </a:solidFill>
+        <a:effectLst/>
+      </p:bgPr>
+    </p:bg>
+    <p:spTree>
+      <p:nvGrpSpPr>
+        <p:cNvPr id="1" name=""/>
+        <p:cNvGrpSpPr/>
+        <p:nvPr/>
+      </p:nvGrpSpPr>
+      <p:grpSpPr/>
+      <p:sp>
+        <p:nvSpPr>
+          <p:cNvPr id="2" name="Rectangle 1"/>
+          <p:cNvSpPr/>
+          <p:nvPr/>
+        </p:nvSpPr>
+        <p:spPr>
+          <a:xfrm>
+            <a:off x="548640" y="502920"/>
+            <a:ext cx="73152" cy="548640"/>
+          </a:xfrm>
+          <a:prstGeom prst="rect">
+            <a:avLst/>
+          </a:prstGeom>
+          <a:solidFill>
+            <a:srgbClr val="3DD6C6"/>
+          </a:solidFill>
+          <a:ln>
+            <a:noFill/>
+          </a:ln>
+        </p:spPr>
+        <p:style>
+          <a:lnRef idx="1">
+            <a:schemeClr val="accent1"/>
+          </a:lnRef>
+          <a:fillRef idx="3">
+            <a:schemeClr val="accent1"/>
+          </a:fillRef>
+          <a:effectRef idx="2">
+            <a:schemeClr val="accent1"/>
+          </a:effectRef>
+          <a:fontRef idx="minor">
+            <a:schemeClr val="lt1"/>
+          </a:fontRef>
+        </p:style>
+        <p:txBody>
+          <a:bodyPr rtlCol="0" anchor="ctr"/>
+          <a:lstStyle/>
+          <a:p>
+            <a:pPr algn="ctr"/>
+          </a:p>
+        </p:txBody>
+      </p:sp>
+      <p:sp>
+        <p:nvSpPr>
+          <p:cNvPr id="3" name="TextBox 2"/>
+          <p:cNvSpPr txBox="1"/>
+          <p:nvPr/>
+        </p:nvSpPr>
+        <p:spPr>
+          <a:xfrm>
+            <a:off x="777240" y="411480"/>
+            <a:ext cx="10515600" cy="731520"/>
+          </a:xfrm>
+          <a:prstGeom prst="rect">
+            <a:avLst/>
+          </a:prstGeom>
+          <a:noFill/>
+        </p:spPr>
+        <p:txBody>
+          <a:bodyPr wrap="square">
+            <a:spAutoFit/>
+          </a:bodyPr>
+          <a:lstStyle/>
+          <a:p>
+            <a:pPr>
+              <a:spcAft>
+                <a:spcPts val="800"/>
+              </a:spcAft>
+              <a:defRPr sz="3000" b="1">
+                <a:solidFill>
+                  <a:srgbClr val="F2F4F8"/>
+                </a:solidFill>
+                <a:latin typeface="Calibri"/>
+              </a:defRPr>
+            </a:pPr>
+            <a:r>
               <a:t>Portfolio performance</a:t>
             </a:r>
           </a:p>
@@ -5287,7 +6306,7 @@
         </p:nvGraphicFramePr>
         <p:xfrm>
           <a:off x="822960" y="1371600"/>
-          <a:ext cx="10515600" cy="4389120"/>
+          <a:ext cx="10515600" cy="4754880"/>
         </p:xfrm>
         <a:graphic>
           <a:graphicData uri="http://schemas.openxmlformats.org/drawingml/2006/table">
@@ -5484,7 +6503,7 @@
                         </a:defRPr>
                       </a:pPr>
                       <a:r>
-                        <a:t>0.08</a:t>
+                        <a:t>0.07</a:t>
                       </a:r>
                     </a:p>
                   </a:txBody>
@@ -5508,7 +6527,7 @@
                         </a:defRPr>
                       </a:pPr>
                       <a:r>
-                        <a:t>0.78</a:t>
+                        <a:t>0.84</a:t>
                       </a:r>
                     </a:p>
                   </a:txBody>
@@ -5704,7 +6723,7 @@
                         </a:defRPr>
                       </a:pPr>
                       <a:r>
-                        <a:t>0.08</a:t>
+                        <a:t>0.09</a:t>
                       </a:r>
                     </a:p>
                   </a:txBody>
@@ -5752,7 +6771,7 @@
                         </a:defRPr>
                       </a:pPr>
                       <a:r>
-                        <a:t>0.68</a:t>
+                        <a:t>0.86</a:t>
                       </a:r>
                     </a:p>
                   </a:txBody>
@@ -5777,6 +6796,128 @@
                       </a:pPr>
                       <a:r>
                         <a:t>-0.23</a:t>
+                      </a:r>
+                    </a:p>
+                  </a:txBody>
+                  <a:tcPr>
+                    <a:solidFill>
+                      <a:srgbClr val="161C28"/>
+                    </a:solidFill>
+                  </a:tcPr>
+                </a:tc>
+              </a:tr>
+              <a:tr h="365760">
+                <a:tc>
+                  <a:txBody>
+                    <a:bodyPr/>
+                    <a:lstStyle/>
+                    <a:p>
+                      <a:pPr>
+                        <a:defRPr sz="1200" b="0">
+                          <a:solidFill>
+                            <a:srgbClr val="F2F4F8"/>
+                          </a:solidFill>
+                          <a:latin typeface="Calibri"/>
+                        </a:defRPr>
+                      </a:pPr>
+                      <a:r>
+                        <a:t>BL_ML_Raw_Regime</a:t>
+                      </a:r>
+                    </a:p>
+                  </a:txBody>
+                  <a:tcPr>
+                    <a:solidFill>
+                      <a:srgbClr val="161C28"/>
+                    </a:solidFill>
+                  </a:tcPr>
+                </a:tc>
+                <a:tc>
+                  <a:txBody>
+                    <a:bodyPr/>
+                    <a:lstStyle/>
+                    <a:p>
+                      <a:pPr>
+                        <a:defRPr sz="1200" b="0">
+                          <a:solidFill>
+                            <a:srgbClr val="F2F4F8"/>
+                          </a:solidFill>
+                          <a:latin typeface="Calibri"/>
+                        </a:defRPr>
+                      </a:pPr>
+                      <a:r>
+                        <a:t>0.07</a:t>
+                      </a:r>
+                    </a:p>
+                  </a:txBody>
+                  <a:tcPr>
+                    <a:solidFill>
+                      <a:srgbClr val="161C28"/>
+                    </a:solidFill>
+                  </a:tcPr>
+                </a:tc>
+                <a:tc>
+                  <a:txBody>
+                    <a:bodyPr/>
+                    <a:lstStyle/>
+                    <a:p>
+                      <a:pPr>
+                        <a:defRPr sz="1200" b="0">
+                          <a:solidFill>
+                            <a:srgbClr val="F2F4F8"/>
+                          </a:solidFill>
+                          <a:latin typeface="Calibri"/>
+                        </a:defRPr>
+                      </a:pPr>
+                      <a:r>
+                        <a:t>0.08</a:t>
+                      </a:r>
+                    </a:p>
+                  </a:txBody>
+                  <a:tcPr>
+                    <a:solidFill>
+                      <a:srgbClr val="161C28"/>
+                    </a:solidFill>
+                  </a:tcPr>
+                </a:tc>
+                <a:tc>
+                  <a:txBody>
+                    <a:bodyPr/>
+                    <a:lstStyle/>
+                    <a:p>
+                      <a:pPr>
+                        <a:defRPr sz="1200" b="0">
+                          <a:solidFill>
+                            <a:srgbClr val="F2F4F8"/>
+                          </a:solidFill>
+                          <a:latin typeface="Calibri"/>
+                        </a:defRPr>
+                      </a:pPr>
+                      <a:r>
+                        <a:t>0.73</a:t>
+                      </a:r>
+                    </a:p>
+                  </a:txBody>
+                  <a:tcPr>
+                    <a:solidFill>
+                      <a:srgbClr val="161C28"/>
+                    </a:solidFill>
+                  </a:tcPr>
+                </a:tc>
+                <a:tc>
+                  <a:txBody>
+                    <a:bodyPr/>
+                    <a:lstStyle/>
+                    <a:p>
+                      <a:pPr>
+                        <a:defRPr sz="1200" b="0">
+                          <a:solidFill>
+                            <a:srgbClr val="F2F4F8"/>
+                          </a:solidFill>
+                          <a:latin typeface="Calibri"/>
+                        </a:defRPr>
+                      </a:pPr>
+                      <a:r>
+                        <a:t>-0.17</a:t>
                       </a:r>
                     </a:p>
                   </a:txBody>
@@ -6775,181 +7916,6 @@
 </p:sld>
 </file>
 
-<file path=ppt/slides/slide8.xml><?xml version="1.0" encoding="utf-8"?>
-<p:sld xmlns:a="http://schemas.openxmlformats.org/drawingml/2006/main" xmlns:p="http://schemas.openxmlformats.org/presentationml/2006/main" xmlns:r="http://schemas.openxmlformats.org/officeDocument/2006/relationships">
-  <p:cSld>
-    <p:bg>
-      <p:bgPr>
-        <a:solidFill>
-          <a:srgbClr val="0B0F17"/>
-        </a:solidFill>
-        <a:effectLst/>
-      </p:bgPr>
-    </p:bg>
-    <p:spTree>
-      <p:nvGrpSpPr>
-        <p:cNvPr id="1" name=""/>
-        <p:cNvGrpSpPr/>
-        <p:nvPr/>
-      </p:nvGrpSpPr>
-      <p:grpSpPr/>
-      <p:sp>
-        <p:nvSpPr>
-          <p:cNvPr id="2" name="Rectangle 1"/>
-          <p:cNvSpPr/>
-          <p:nvPr/>
-        </p:nvSpPr>
-        <p:spPr>
-          <a:xfrm>
-            <a:off x="548640" y="502920"/>
-            <a:ext cx="73152" cy="548640"/>
-          </a:xfrm>
-          <a:prstGeom prst="rect">
-            <a:avLst/>
-          </a:prstGeom>
-          <a:solidFill>
-            <a:srgbClr val="3DD6C6"/>
-          </a:solidFill>
-          <a:ln>
-            <a:noFill/>
-          </a:ln>
-        </p:spPr>
-        <p:style>
-          <a:lnRef idx="1">
-            <a:schemeClr val="accent1"/>
-          </a:lnRef>
-          <a:fillRef idx="3">
-            <a:schemeClr val="accent1"/>
-          </a:fillRef>
-          <a:effectRef idx="2">
-            <a:schemeClr val="accent1"/>
-          </a:effectRef>
-          <a:fontRef idx="minor">
-            <a:schemeClr val="lt1"/>
-          </a:fontRef>
-        </p:style>
-        <p:txBody>
-          <a:bodyPr rtlCol="0" anchor="ctr"/>
-          <a:lstStyle/>
-          <a:p>
-            <a:pPr algn="ctr"/>
-          </a:p>
-        </p:txBody>
-      </p:sp>
-      <p:sp>
-        <p:nvSpPr>
-          <p:cNvPr id="3" name="TextBox 2"/>
-          <p:cNvSpPr txBox="1"/>
-          <p:nvPr/>
-        </p:nvSpPr>
-        <p:spPr>
-          <a:xfrm>
-            <a:off x="777240" y="411480"/>
-            <a:ext cx="10515600" cy="731520"/>
-          </a:xfrm>
-          <a:prstGeom prst="rect">
-            <a:avLst/>
-          </a:prstGeom>
-          <a:noFill/>
-        </p:spPr>
-        <p:txBody>
-          <a:bodyPr wrap="square">
-            <a:spAutoFit/>
-          </a:bodyPr>
-          <a:lstStyle/>
-          <a:p>
-            <a:pPr>
-              <a:spcAft>
-                <a:spcPts val="800"/>
-              </a:spcAft>
-              <a:defRPr sz="3000" b="1">
-                <a:solidFill>
-                  <a:srgbClr val="F2F4F8"/>
-                </a:solidFill>
-                <a:latin typeface="Calibri"/>
-              </a:defRPr>
-            </a:pPr>
-            <a:r>
-              <a:t>Cumulative returns</a:t>
-            </a:r>
-          </a:p>
-        </p:txBody>
-      </p:sp>
-      <p:sp>
-        <p:nvSpPr>
-          <p:cNvPr id="4" name="Rectangle 3"/>
-          <p:cNvSpPr/>
-          <p:nvPr/>
-        </p:nvSpPr>
-        <p:spPr>
-          <a:xfrm>
-            <a:off x="1920240" y="1371600"/>
-            <a:ext cx="8046720" cy="4480560"/>
-          </a:xfrm>
-          <a:prstGeom prst="rect">
-            <a:avLst/>
-          </a:prstGeom>
-          <a:solidFill>
-            <a:srgbClr val="FFFFFF"/>
-          </a:solidFill>
-          <a:ln>
-            <a:noFill/>
-          </a:ln>
-        </p:spPr>
-        <p:style>
-          <a:lnRef idx="1">
-            <a:schemeClr val="accent1"/>
-          </a:lnRef>
-          <a:fillRef idx="3">
-            <a:schemeClr val="accent1"/>
-          </a:fillRef>
-          <a:effectRef idx="2">
-            <a:schemeClr val="accent1"/>
-          </a:effectRef>
-          <a:fontRef idx="minor">
-            <a:schemeClr val="lt1"/>
-          </a:fontRef>
-        </p:style>
-        <p:txBody>
-          <a:bodyPr rtlCol="0" anchor="ctr"/>
-          <a:lstStyle/>
-          <a:p>
-            <a:pPr algn="ctr"/>
-          </a:p>
-        </p:txBody>
-      </p:sp>
-      <p:pic>
-        <p:nvPicPr>
-          <p:cNvPr id="5" name="Picture 4" descr="07_cumulative_returns.png"/>
-          <p:cNvPicPr>
-            <a:picLocks noChangeAspect="1"/>
-          </p:cNvPicPr>
-          <p:nvPr/>
-        </p:nvPicPr>
-        <p:blipFill>
-          <a:blip r:embed="rId2"/>
-          <a:stretch>
-            <a:fillRect/>
-          </a:stretch>
-        </p:blipFill>
-        <p:spPr>
-          <a:xfrm>
-            <a:off x="2011680" y="1463040"/>
-            <a:ext cx="7863840" cy="3931920"/>
-          </a:xfrm>
-          <a:prstGeom prst="rect">
-            <a:avLst/>
-          </a:prstGeom>
-        </p:spPr>
-      </p:pic>
-    </p:spTree>
-  </p:cSld>
-  <p:clrMapOvr>
-    <a:masterClrMapping/>
-  </p:clrMapOvr>
-</p:sld>
-</file>
-
 <file path=ppt/slides/slide9.xml><?xml version="1.0" encoding="utf-8"?>
 <p:sld xmlns:a="http://schemas.openxmlformats.org/drawingml/2006/main" xmlns:p="http://schemas.openxmlformats.org/presentationml/2006/main" xmlns:r="http://schemas.openxmlformats.org/officeDocument/2006/relationships">
   <p:cSld>
@@ -7045,7 +8011,7 @@
               </a:defRPr>
             </a:pPr>
             <a:r>
-              <a:t>Statistical significance</a:t>
+              <a:t>Cumulative returns</a:t>
             </a:r>
           </a:p>
         </p:txBody>
@@ -7058,8 +8024,8 @@
         </p:nvSpPr>
         <p:spPr>
           <a:xfrm>
-            <a:off x="731520" y="1371600"/>
-            <a:ext cx="5943600" cy="4480560"/>
+            <a:off x="1920240" y="1371600"/>
+            <a:ext cx="8046720" cy="4480560"/>
           </a:xfrm>
           <a:prstGeom prst="rect">
             <a:avLst/>
@@ -7095,7 +8061,7 @@
       </p:sp>
       <p:pic>
         <p:nvPicPr>
-          <p:cNvPr id="5" name="Picture 4" descr="09_sharpe_significance.png"/>
+          <p:cNvPr id="5" name="Picture 4" descr="07_cumulative_returns.png"/>
           <p:cNvPicPr>
             <a:picLocks noChangeAspect="1"/>
           </p:cNvPicPr>
@@ -7109,69 +8075,14 @@
         </p:blipFill>
         <p:spPr>
           <a:xfrm>
-            <a:off x="822960" y="1463040"/>
-            <a:ext cx="5760720" cy="3127248"/>
+            <a:off x="2011680" y="1463040"/>
+            <a:ext cx="7863840" cy="3931920"/>
           </a:xfrm>
           <a:prstGeom prst="rect">
             <a:avLst/>
           </a:prstGeom>
         </p:spPr>
       </p:pic>
-      <p:sp>
-        <p:nvSpPr>
-          <p:cNvPr id="6" name="TextBox 5"/>
-          <p:cNvSpPr txBox="1"/>
-          <p:nvPr/>
-        </p:nvSpPr>
-        <p:spPr>
-          <a:xfrm>
-            <a:off x="6949440" y="1645920"/>
-            <a:ext cx="4754880" cy="4114800"/>
-          </a:xfrm>
-          <a:prstGeom prst="rect">
-            <a:avLst/>
-          </a:prstGeom>
-          <a:noFill/>
-        </p:spPr>
-        <p:txBody>
-          <a:bodyPr wrap="square">
-            <a:spAutoFit/>
-          </a:bodyPr>
-          <a:lstStyle/>
-          <a:p>
-            <a:pPr>
-              <a:spcAft>
-                <a:spcPts val="800"/>
-              </a:spcAft>
-              <a:defRPr sz="1600" b="0">
-                <a:solidFill>
-                  <a:srgbClr val="F2F4F8"/>
-                </a:solidFill>
-                <a:latin typeface="Calibri"/>
-              </a:defRPr>
-            </a:pPr>
-            <a:r>
-              <a:t>Regime ablation, Sharpe difference: +0.10 (95% interval -0.03 to 0.21, p = 0.119), not statistically significant</a:t>
-            </a:r>
-          </a:p>
-          <a:p>
-            <a:pPr>
-              <a:spcAft>
-                <a:spcPts val="800"/>
-              </a:spcAft>
-              <a:defRPr sz="1600" b="0">
-                <a:solidFill>
-                  <a:srgbClr val="F2F4F8"/>
-                </a:solidFill>
-                <a:latin typeface="Calibri"/>
-              </a:defRPr>
-            </a:pPr>
-            <a:r>
-              <a:t>In stressed months the regime-aware portfolio's worst-5% average monthly return was -4.67% against -6.83% without regime scaling.</a:t>
-            </a:r>
-          </a:p>
-        </p:txBody>
-      </p:sp>
     </p:spTree>
   </p:cSld>
   <p:clrMapOvr>

</xml_diff>

<commit_message>
Implement updates for better performance
</commit_message>
<xml_diff>
--- a/reports/Kairos_Deck.pptx
+++ b/reports/Kairos_Deck.pptx
@@ -3359,7 +3359,7 @@
               </a:defRPr>
             </a:pPr>
             <a:r>
-              <a:t>Regime ablation, Sharpe difference: -0.02 (95% interval -0.15 to 0.10, p = 0.791), not statistically significant</a:t>
+              <a:t>Regime ablation, Sharpe difference: -0.02 (95% interval -0.15 to 0.10, p = 0.767), not statistically significant</a:t>
             </a:r>
           </a:p>
           <a:p>
@@ -3375,7 +3375,7 @@
               </a:defRPr>
             </a:pPr>
             <a:r>
-              <a:t>In stressed months the regime-aware portfolio's worst-5% average monthly return was -4.29% against -7.08% without regime scaling.</a:t>
+              <a:t>In stressed months the regime-aware portfolio's worst-5% average monthly return was -4.25% against -7.04% without regime scaling.</a:t>
             </a:r>
           </a:p>
         </p:txBody>
@@ -3883,7 +3883,7 @@
               </a:defRPr>
             </a:pPr>
             <a:r>
-              <a:t>BL_ML_Regime Sharpe: 0.71</a:t>
+              <a:t>BL_ML_Regime Sharpe: 0.69</a:t>
             </a:r>
           </a:p>
         </p:txBody>
@@ -4288,7 +4288,7 @@
               </a:defRPr>
             </a:pPr>
             <a:r>
-              <a:t>Sharpe range: 0.61 to 0.90</a:t>
+              <a:t>Sharpe range: 0.59 to 0.90</a:t>
             </a:r>
           </a:p>
         </p:txBody>
@@ -4502,7 +4502,7 @@
               </a:defRPr>
             </a:pPr>
             <a:r>
-              <a:t>reference: Sharpe gain over its prior portfolio -0.08 (p = 0.32)</a:t>
+              <a:t>reference: Sharpe gain over its prior portfolio -0.12 (p = 0.17)</a:t>
             </a:r>
           </a:p>
           <a:p>
@@ -4518,7 +4518,7 @@
               </a:defRPr>
             </a:pPr>
             <a:r>
-              <a:t>equal: Sharpe gain over its prior portfolio -0.13 (p = 0.09)</a:t>
+              <a:t>equal: Sharpe gain over its prior portfolio -0.15 (p = 0.05)</a:t>
             </a:r>
           </a:p>
           <a:p>
@@ -4534,7 +4534,7 @@
               </a:defRPr>
             </a:pPr>
             <a:r>
-              <a:t>inverse_vol: Sharpe gain over its prior portfolio -0.12 (p = 0.22)</a:t>
+              <a:t>inverse_vol: Sharpe gain over its prior portfolio -0.15 (p = 0.14)</a:t>
             </a:r>
           </a:p>
         </p:txBody>
@@ -4681,7 +4681,7 @@
               </a:defRPr>
             </a:pPr>
             <a:r>
-              <a:t>The research hypothesis is not supported. The highest Sharpe ratio among the Kairos portfolios and the classical benchmarks belongs to Static_60_40. The Sharpe difference of BL_ML_Regime to the best classical benchmark (Static_60_40) is -0.14 (95% interval -0.38 to 0.06, p = 0.231), not statistically significant; BL_ML_Regime is significantly better than 1 and significantly worse than 0 of the 5 classical benchmarks (5% level). For BL_ML_Regime_IC the difference is -0.12 (95% interval -0.34 to 0.06, p = 0.234), not statistically significant.</a:t>
+              <a:t>The research hypothesis is not supported. The highest Sharpe ratio among the Kairos portfolios and the classical benchmarks belongs to Static_60_40. The Sharpe difference of BL_ML_Regime to the best classical benchmark (Static_60_40) is -0.18 (95% interval -0.43 to 0.03, p = 0.134), not statistically significant; BL_ML_Regime is significantly better than 1 and significantly worse than 0 of the 5 classical benchmarks (5% level). For BL_ML_Regime_IC the difference is -0.12 (95% interval -0.34 to 0.05, p = 0.216), not statistically significant.</a:t>
             </a:r>
           </a:p>
           <a:p>
@@ -5563,7 +5563,7 @@
               </a:defRPr>
             </a:pPr>
             <a:r>
-              <a:t>Mean stacked IC: -0.047</a:t>
+              <a:t>Mean stacked IC: -0.062</a:t>
             </a:r>
           </a:p>
           <a:p>
@@ -5627,7 +5627,7 @@
               </a:defRPr>
             </a:pPr>
             <a:r>
-              <a:t>Hit rate below always-up baseline: 8 of 9</a:t>
+              <a:t>Hit rate below always-up baseline: 9 of 9</a:t>
             </a:r>
           </a:p>
         </p:txBody>
@@ -5857,7 +5857,7 @@
               </a:defRPr>
             </a:pPr>
             <a:r>
-              <a:t>as specified: mean IC -0.008</a:t>
+              <a:t>as specified: mean IC -0.010</a:t>
             </a:r>
           </a:p>
           <a:p>
@@ -5873,7 +5873,7 @@
               </a:defRPr>
             </a:pPr>
             <a:r>
-              <a:t>no regime features: mean IC -0.034</a:t>
+              <a:t>no regime features: mean IC -0.020</a:t>
             </a:r>
           </a:p>
           <a:p>
@@ -5889,7 +5889,7 @@
               </a:defRPr>
             </a:pPr>
             <a:r>
-              <a:t>no stress features: mean IC +0.018</a:t>
+              <a:t>no stress features: mean IC +0.002</a:t>
             </a:r>
           </a:p>
           <a:p>
@@ -5905,7 +5905,7 @@
               </a:defRPr>
             </a:pPr>
             <a:r>
-              <a:t>longer initial window: mean IC -0.008</a:t>
+              <a:t>longer initial window: mean IC -0.010</a:t>
             </a:r>
           </a:p>
           <a:p>
@@ -5921,7 +5921,7 @@
               </a:defRPr>
             </a:pPr>
             <a:r>
-              <a:t>no regime longer window: mean IC -0.034</a:t>
+              <a:t>no regime longer window: mean IC -0.020</a:t>
             </a:r>
           </a:p>
         </p:txBody>
@@ -6167,7 +6167,7 @@
               </a:defRPr>
             </a:pPr>
             <a:r>
-              <a:t>Calibrated forecast R2: -0.019 before, -0.012 after 2019</a:t>
+              <a:t>Calibrated forecast R2: -0.025 before, -0.014 after 2019</a:t>
             </a:r>
           </a:p>
           <a:p>
@@ -6479,7 +6479,7 @@
                         </a:defRPr>
                       </a:pPr>
                       <a:r>
-                        <a:t>0.08</a:t>
+                        <a:t>0.07</a:t>
                       </a:r>
                     </a:p>
                   </a:txBody>
@@ -6527,7 +6527,7 @@
                         </a:defRPr>
                       </a:pPr>
                       <a:r>
-                        <a:t>0.84</a:t>
+                        <a:t>0.80</a:t>
                       </a:r>
                     </a:p>
                   </a:txBody>
@@ -6771,7 +6771,7 @@
                         </a:defRPr>
                       </a:pPr>
                       <a:r>
-                        <a:t>0.86</a:t>
+                        <a:t>0.82</a:t>
                       </a:r>
                     </a:p>
                   </a:txBody>
@@ -6893,7 +6893,7 @@
                         </a:defRPr>
                       </a:pPr>
                       <a:r>
-                        <a:t>0.73</a:t>
+                        <a:t>0.74</a:t>
                       </a:r>
                     </a:p>
                   </a:txBody>

</xml_diff>